<commit_message>
Adjust presentation to improve its readability
</commit_message>
<xml_diff>
--- a/docs/cursor-api-presentation.pptx
+++ b/docs/cursor-api-presentation.pptx
@@ -1060,7 +1060,8 @@
             <a:r>
               <a:rPr lang="en-US" dirty="0"/>
               <a:t>Обратный курсор — зеркальная история.
-Клиент передаёт prev из прошлого ответа. Условие «меньше»: либо тот же author и меньший id, либо строго меньший author. В БД сортировка по убыванию, LIMIT тот же. Затем результат разворачиваем — клиент получает записи в ожидаемом порядке.</a:t>
+Клиент передаёт prev из прошлого ответа. Условие «меньше»: либо тот же author и меньший id, либо строго меньший author. Сортировка в БД — по убыванию, LIMIT тот же.
+Почему DESC: база идёт к более ранним записям и первой находит ближайшего соседа. Порядок для клиента из-за этого окажется перевёрнутым — на следующем слайде покажу, что с этим делать.</a:t>
             </a:r>
             <a:endParaRPr lang="en-US" dirty="0"/>
           </a:p>
@@ -1148,9 +1149,9 @@
           <a:p>
             <a:r>
               <a:rPr lang="en-US" dirty="0"/>
-              <a:t>Обратный курсор — зеркальная история.
-Условие «меньше», сортировка в запросе к БД — по убыванию, LIMIT тот же. Но клиенту мы отдаём список в ожидаемом порядке чтения вперёд, поэтому после выборки результат разворачиваем.
-prev строится от первой записи текущей страницы и помечается как backward — параметр f равен false. Так клиент ходит туда-сюда относительно текущей позиции, не считая номера страниц.</a:t>
+              <a:t>Жёлтая строка — первая запись текущей страницы: от неё построен prev. Идём назад и должны получить John с id=37 и John с id=38.
+База при DESC сначала находит ближайшего соседа: 38, потом 37. Клиенту такой порядок не подходит — он ждёт тот же, что при чтении вперёд. Поэтому список разворачиваем: 37, затем 38.
+В курсоре f равно false. Клиент ходит туда-сюда относительно позиции, не считая номера страниц.</a:t>
             </a:r>
             <a:endParaRPr lang="en-US" dirty="0"/>
           </a:p>
@@ -1604,7 +1605,7 @@
               <a:t>Подведём итог.
 Cursor API — это пагинация через позицию: стабильнее и предсказуемее offset на больших и «живых» датасетах.
 Цена — другой UX: удобные переходы по next или prev курсору, а не произвольный прыжок на "страницу номер сто".
-Если хотите посмотреть рабочий пример — ссылка на репозиторий с кодом проекта, где есть подробный README с curl-командами, находится в описании к ролику.</a:t>
+Если хотите посмотреть рабочий пример - ссылка на репозиторий с кодом проекта находится в описании к ролику.</a:t>
             </a:r>
             <a:endParaRPr lang="en-US" dirty="0"/>
           </a:p>

</xml_diff>